<commit_message>
batch: 560/565 gemeenten (tussentijds)
</commit_message>
<xml_diff>
--- a/Fluctus_Laadplan_Bastenaken.pptx
+++ b/Fluctus_Laadplan_Bastenaken.pptx
@@ -118,7 +118,7 @@
 </p:presentation>
 </file>
 
-<file path=ppt/charts/chart553.xml><?xml version="1.0" encoding="utf-8"?>
+<file path=ppt/charts/chart555.xml><?xml version="1.0" encoding="utf-8"?>
 <c:chartSpace xmlns:c="http://schemas.openxmlformats.org/drawingml/2006/chart" xmlns:a="http://schemas.openxmlformats.org/drawingml/2006/main" xmlns:r="http://schemas.openxmlformats.org/officeDocument/2006/relationships">
   <c:date1904 val="0"/>
   <c:roundedCorners val="1"/>
@@ -8816,7 +8816,46 @@
       </p:sp>
       <p:sp>
         <p:nvSpPr>
-          <p:cNvPr id="10" name="Shape 7"/>
+          <p:cNvPr id="10" name="Text 7"/>
+          <p:cNvSpPr/>
+          <p:nvPr/>
+        </p:nvSpPr>
+        <p:spPr>
+          <a:xfrm>
+            <a:off x="640080" y="6071616"/>
+            <a:ext cx="10058400" cy="237744"/>
+          </a:xfrm>
+          <a:prstGeom prst="rect">
+            <a:avLst/>
+          </a:prstGeom>
+          <a:noFill/>
+          <a:ln/>
+        </p:spPr>
+        <p:txBody>
+          <a:bodyPr wrap="square" lIns="0" tIns="0" rIns="0" bIns="0" rtlCol="0" anchor="ctr"/>
+          <a:lstStyle/>
+          <a:p>
+            <a:pPr indent="0" marL="0">
+              <a:buNone/>
+            </a:pPr>
+            <a:r>
+              <a:rPr lang="en-US" sz="800" i="1" dirty="0">
+                <a:solidFill>
+                  <a:srgbClr val="5A6473"/>
+                </a:solidFill>
+                <a:latin typeface="Arial" pitchFamily="34" charset="0"/>
+                <a:ea typeface="Arial" pitchFamily="34" charset="-122"/>
+                <a:cs typeface="Arial" pitchFamily="34" charset="-120"/>
+              </a:rPr>
+              <a:t>Bron bestaande laadpunten: Departement Mobiliteit en Openbare Werken (Vlaanderen).</a:t>
+            </a:r>
+            <a:endParaRPr lang="en-US" sz="800" dirty="0"/>
+          </a:p>
+        </p:txBody>
+      </p:sp>
+      <p:sp>
+        <p:nvSpPr>
+          <p:cNvPr id="11" name="Shape 8"/>
           <p:cNvSpPr/>
           <p:nvPr/>
         </p:nvSpPr>
@@ -8836,7 +8875,7 @@
       </p:sp>
       <p:pic>
         <p:nvPicPr>
-          <p:cNvPr id="11" name="Image 1" descr="preencoded.png">    </p:cNvPr>
+          <p:cNvPr id="12" name="Image 1" descr="preencoded.png">    </p:cNvPr>
           <p:cNvPicPr>
             <a:picLocks noChangeAspect="1"/>
           </p:cNvPicPr>
@@ -8860,7 +8899,7 @@
       </p:pic>
       <p:sp>
         <p:nvSpPr>
-          <p:cNvPr id="12" name="Text 8"/>
+          <p:cNvPr id="13" name="Text 9"/>
           <p:cNvSpPr/>
           <p:nvPr/>
         </p:nvSpPr>
@@ -8902,7 +8941,7 @@
       </p:sp>
       <p:sp>
         <p:nvSpPr>
-          <p:cNvPr id="13" name="Shape 9"/>
+          <p:cNvPr id="14" name="Shape 10"/>
           <p:cNvSpPr/>
           <p:nvPr/>
         </p:nvSpPr>
@@ -8922,7 +8961,7 @@
       </p:sp>
       <p:pic>
         <p:nvPicPr>
-          <p:cNvPr id="14" name="Image 2" descr="preencoded.png">    </p:cNvPr>
+          <p:cNvPr id="15" name="Image 2" descr="preencoded.png">    </p:cNvPr>
           <p:cNvPicPr>
             <a:picLocks noChangeAspect="1"/>
           </p:cNvPicPr>
@@ -8946,7 +8985,7 @@
       </p:pic>
       <p:sp>
         <p:nvSpPr>
-          <p:cNvPr id="15" name="Text 10"/>
+          <p:cNvPr id="16" name="Text 11"/>
           <p:cNvSpPr/>
           <p:nvPr/>
         </p:nvSpPr>
@@ -8988,7 +9027,7 @@
       </p:sp>
       <p:sp>
         <p:nvSpPr>
-          <p:cNvPr id="16" name="Shape 11"/>
+          <p:cNvPr id="17" name="Shape 12"/>
           <p:cNvSpPr/>
           <p:nvPr/>
         </p:nvSpPr>
@@ -9008,7 +9047,7 @@
       </p:sp>
       <p:pic>
         <p:nvPicPr>
-          <p:cNvPr id="17" name="Image 3" descr="preencoded.png">    </p:cNvPr>
+          <p:cNvPr id="18" name="Image 3" descr="preencoded.png">    </p:cNvPr>
           <p:cNvPicPr>
             <a:picLocks noChangeAspect="1"/>
           </p:cNvPicPr>
@@ -9032,7 +9071,7 @@
       </p:pic>
       <p:sp>
         <p:nvSpPr>
-          <p:cNvPr id="18" name="Text 12"/>
+          <p:cNvPr id="19" name="Text 13"/>
           <p:cNvSpPr/>
           <p:nvPr/>
         </p:nvSpPr>
@@ -9074,7 +9113,7 @@
       </p:sp>
       <p:sp>
         <p:nvSpPr>
-          <p:cNvPr id="19" name="Text 13"/>
+          <p:cNvPr id="20" name="Text 14"/>
           <p:cNvSpPr/>
           <p:nvPr/>
         </p:nvSpPr>
@@ -9113,7 +9152,7 @@
       </p:sp>
       <p:sp>
         <p:nvSpPr>
-          <p:cNvPr id="20" name="Text 14"/>
+          <p:cNvPr id="21" name="Text 15"/>
           <p:cNvSpPr/>
           <p:nvPr/>
         </p:nvSpPr>

</xml_diff>